<commit_message>
Final deck with corrected metrics, Phase 1 dashboard, team authors
</commit_message>
<xml_diff>
--- a/FairCredit_ML_Bubble_2026.pptx
+++ b/FairCredit_ML_Bubble_2026.pptx
@@ -2178,7 +2178,7 @@
                 <a:ea typeface="Cambria" pitchFamily="34" charset="-122"/>
                 <a:cs typeface="Cambria" pitchFamily="34" charset="-120"/>
               </a:rPr>
-              <a:t>0.028→0.001</a:t>
+              <a:t>~20%</a:t>
             </a:r>
             <a:endParaRPr lang="en-US" sz="2600" dirty="0"/>
           </a:p>
@@ -2217,7 +2217,7 @@
                 <a:ea typeface="Calibri" pitchFamily="34" charset="-122"/>
                 <a:cs typeface="Calibri" pitchFamily="34" charset="-120"/>
               </a:rPr>
-              <a:t>bias gap cut</a:t>
+              <a:t>equal-opp gap ↓</a:t>
             </a:r>
             <a:endParaRPr lang="en-US" sz="1300" dirty="0"/>
           </a:p>
@@ -2334,7 +2334,7 @@
                 <a:ea typeface="Calibri" pitchFamily="34" charset="-122"/>
                 <a:cs typeface="Calibri" pitchFamily="34" charset="-120"/>
               </a:rPr>
-              <a:t>Siddharth Kancharla  ·  IIIT Sri City</a:t>
+              <a:t>Siddharth Kancharla &amp; Kancharla Sricharan  ·  IIIT Sri City</a:t>
             </a:r>
             <a:endParaRPr lang="en-US" sz="1300" dirty="0"/>
           </a:p>
@@ -3586,7 +3586,7 @@
                 <a:ea typeface="Calibri" pitchFamily="34" charset="-122"/>
                 <a:cs typeface="Calibri" pitchFamily="34" charset="-120"/>
               </a:rPr>
-              <a:t>5:1 threshold, 3.2% lower expected cost</a:t>
+              <a:t>5:1 threshold, 1.8% lower expected cost</a:t>
             </a:r>
             <a:endParaRPr lang="en-US" sz="1300" dirty="0"/>
           </a:p>
@@ -3684,7 +3684,7 @@
                 <a:ea typeface="Calibri" pitchFamily="34" charset="-122"/>
                 <a:cs typeface="Calibri" pitchFamily="34" charset="-120"/>
               </a:rPr>
-              <a:t>equal-opportunity gap 0.028 → 0.001</a:t>
+              <a:t>equal-opportunity gap 0.0161 → 0.0129</a:t>
             </a:r>
             <a:endParaRPr lang="en-US" sz="1300" dirty="0"/>
           </a:p>
@@ -4017,7 +4017,7 @@
                 <a:ea typeface="Calibri" pitchFamily="34" charset="-122"/>
                 <a:cs typeface="Calibri" pitchFamily="34" charset="-120"/>
               </a:rPr>
-              <a:t>Siddharth Kancharla  ·  IIIT Sri City  ·  github.com/&lt;your-handle&gt;/faircredit</a:t>
+              <a:t>Siddharth Kancharla &amp; Kancharla Sricharan  ·  IIIT Sri City  ·  github.com/Sricharan7989/ML-Bubble-2026</a:t>
             </a:r>
             <a:endParaRPr lang="en-US" sz="1300" dirty="0"/>
           </a:p>
@@ -5260,7 +5260,7 @@
                 <a:ea typeface="Calibri" pitchFamily="34" charset="-122"/>
                 <a:cs typeface="Calibri" pitchFamily="34" charset="-120"/>
               </a:rPr>
-              <a:t>engineered behavioural features</a:t>
+              <a:t>features — 19 engineered</a:t>
             </a:r>
             <a:endParaRPr lang="en-US" sz="1250" dirty="0"/>
           </a:p>
@@ -7708,7 +7708,7 @@
                           <a:ea typeface="Calibri" pitchFamily="34" charset="-122"/>
                           <a:cs typeface="Calibri" pitchFamily="34" charset="-120"/>
                         </a:rPr>
-                        <a:t>0.779</a:t>
+                        <a:t>0.780</a:t>
                       </a:r>
                       <a:endParaRPr lang="en-US" sz="1400" dirty="0">
                         <a:latin typeface="Calibri" charset="0"/>
@@ -7776,7 +7776,7 @@
                           <a:ea typeface="Calibri" pitchFamily="34" charset="-122"/>
                           <a:cs typeface="Calibri" pitchFamily="34" charset="-120"/>
                         </a:rPr>
-                        <a:t>0.563</a:t>
+                        <a:t>0.561</a:t>
                       </a:r>
                       <a:endParaRPr lang="en-US" sz="1400" dirty="0">
                         <a:latin typeface="Calibri" charset="0"/>
@@ -7844,7 +7844,7 @@
                           <a:ea typeface="Calibri" pitchFamily="34" charset="-122"/>
                           <a:cs typeface="Calibri" pitchFamily="34" charset="-120"/>
                         </a:rPr>
-                        <a:t>0.795</a:t>
+                        <a:t>0.768</a:t>
                       </a:r>
                       <a:endParaRPr lang="en-US" sz="1400" dirty="0">
                         <a:latin typeface="Calibri" charset="0"/>
@@ -7912,7 +7912,7 @@
                           <a:ea typeface="Calibri" pitchFamily="34" charset="-122"/>
                           <a:cs typeface="Calibri" pitchFamily="34" charset="-120"/>
                         </a:rPr>
-                        <a:t>0.487</a:t>
+                        <a:t>0.492</a:t>
                       </a:r>
                       <a:endParaRPr lang="en-US" sz="1400" dirty="0">
                         <a:latin typeface="Calibri" charset="0"/>
@@ -8118,7 +8118,7 @@
                           <a:ea typeface="Calibri" pitchFamily="34" charset="-122"/>
                           <a:cs typeface="Calibri" pitchFamily="34" charset="-120"/>
                         </a:rPr>
-                        <a:t>0.555</a:t>
+                        <a:t>0.556</a:t>
                       </a:r>
                       <a:endParaRPr lang="en-US" sz="1400" dirty="0">
                         <a:latin typeface="Calibri" charset="0"/>
@@ -8186,7 +8186,7 @@
                           <a:ea typeface="Calibri" pitchFamily="34" charset="-122"/>
                           <a:cs typeface="Calibri" pitchFamily="34" charset="-120"/>
                         </a:rPr>
-                        <a:t>0.797</a:t>
+                        <a:t>0.779</a:t>
                       </a:r>
                       <a:endParaRPr lang="en-US" sz="1400" dirty="0">
                         <a:latin typeface="Calibri" charset="0"/>
@@ -8254,7 +8254,7 @@
                           <a:ea typeface="Calibri" pitchFamily="34" charset="-122"/>
                           <a:cs typeface="Calibri" pitchFamily="34" charset="-120"/>
                         </a:rPr>
-                        <a:t>0.483</a:t>
+                        <a:t>0.488</a:t>
                       </a:r>
                       <a:endParaRPr lang="en-US" sz="1400" dirty="0">
                         <a:latin typeface="Calibri" charset="0"/>
@@ -8528,7 +8528,7 @@
                           <a:ea typeface="Calibri" pitchFamily="34" charset="-122"/>
                           <a:cs typeface="Calibri" pitchFamily="34" charset="-120"/>
                         </a:rPr>
-                        <a:t>0.774</a:t>
+                        <a:t>0.744</a:t>
                       </a:r>
                       <a:endParaRPr lang="en-US" sz="1400" dirty="0">
                         <a:latin typeface="Calibri" charset="0"/>
@@ -8596,7 +8596,7 @@
                           <a:ea typeface="Calibri" pitchFamily="34" charset="-122"/>
                           <a:cs typeface="Calibri" pitchFamily="34" charset="-120"/>
                         </a:rPr>
-                        <a:t>0.492</a:t>
+                        <a:t>0.498</a:t>
                       </a:r>
                       <a:endParaRPr lang="en-US" sz="1400" dirty="0">
                         <a:latin typeface="Calibri" charset="0"/>
@@ -8870,7 +8870,7 @@
                           <a:ea typeface="Calibri" pitchFamily="34" charset="-122"/>
                           <a:cs typeface="Calibri" pitchFamily="34" charset="-120"/>
                         </a:rPr>
-                        <a:t>0.754</a:t>
+                        <a:t>0.725</a:t>
                       </a:r>
                       <a:endParaRPr lang="en-US" sz="1400" dirty="0">
                         <a:latin typeface="Calibri" charset="0"/>
@@ -8938,7 +8938,7 @@
                           <a:ea typeface="Calibri" pitchFamily="34" charset="-122"/>
                           <a:cs typeface="Calibri" pitchFamily="34" charset="-120"/>
                         </a:rPr>
-                        <a:t>0.459</a:t>
+                        <a:t>0.482</a:t>
                       </a:r>
                       <a:endParaRPr lang="en-US" sz="1400" dirty="0">
                         <a:latin typeface="Calibri" charset="0"/>
@@ -9049,7 +9049,7 @@
       </p:sp>
       <p:pic>
         <p:nvPicPr>
-          <p:cNvPr id="6" name="Image 0" descr="outputs/roc_pr_curves.png">    </p:cNvPr>
+          <p:cNvPr id="6" name="Image 0" descr="outputs/metric_bars.png">    </p:cNvPr>
           <p:cNvPicPr>
             <a:picLocks noChangeAspect="1"/>
           </p:cNvPicPr>
@@ -9063,8 +9063,8 @@
         </p:blipFill>
         <p:spPr>
           <a:xfrm>
-            <a:off x="6812280" y="2148840"/>
-            <a:ext cx="4892040" cy="1947672"/>
+            <a:off x="6858000" y="1965960"/>
+            <a:ext cx="4663440" cy="2560320"/>
           </a:xfrm>
           <a:prstGeom prst="rect">
             <a:avLst/>
@@ -9079,8 +9079,8 @@
         </p:nvSpPr>
         <p:spPr>
           <a:xfrm>
-            <a:off x="6812280" y="4297680"/>
-            <a:ext cx="4892040" cy="1463040"/>
+            <a:off x="6858000" y="4617720"/>
+            <a:ext cx="4663440" cy="1463040"/>
           </a:xfrm>
           <a:prstGeom prst="rect">
             <a:avLst/>
@@ -9300,7 +9300,7 @@
       </p:sp>
       <p:pic>
         <p:nvPicPr>
-          <p:cNvPr id="4" name="Image 0" descr="outputs/cost_threshold.png">    </p:cNvPr>
+          <p:cNvPr id="4" name="Image 0" descr="outputs/cost_bars.png">    </p:cNvPr>
           <p:cNvPicPr>
             <a:picLocks noChangeAspect="1"/>
           </p:cNvPicPr>
@@ -9314,8 +9314,8 @@
         </p:blipFill>
         <p:spPr>
           <a:xfrm>
-            <a:off x="548640" y="1691640"/>
-            <a:ext cx="6035040" cy="3730752"/>
+            <a:off x="640080" y="1783080"/>
+            <a:ext cx="5486400" cy="3621024"/>
           </a:xfrm>
           <a:prstGeom prst="rect">
             <a:avLst/>
@@ -9355,7 +9355,7 @@
                 <a:ea typeface="Calibri" pitchFamily="34" charset="-122"/>
                 <a:cs typeface="Calibri" pitchFamily="34" charset="-120"/>
               </a:rPr>
-              <a:t>A false negative (approve a defaulter) loses principal — far costlier than a false positive (reject a good customer). Under a 5:1 cost ratio, sweeping the threshold on validation moves the optimal cutoff to 0.355.</a:t>
+              <a:t>A false negative (approve a defaulter) loses principal — far costlier than a false positive (reject a good customer). Under a 5:1 cost ratio, sweeping the threshold on validation moves the optimal cutoff to 0.375.</a:t>
             </a:r>
             <a:endParaRPr lang="en-US" sz="1500" dirty="0"/>
           </a:p>
@@ -9421,7 +9421,7 @@
                 <a:ea typeface="Cambria" pitchFamily="34" charset="-122"/>
                 <a:cs typeface="Cambria" pitchFamily="34" charset="-120"/>
               </a:rPr>
-              <a:t>3.2%</a:t>
+              <a:t>1.8%</a:t>
             </a:r>
             <a:endParaRPr lang="en-US" sz="5200" dirty="0"/>
           </a:p>
@@ -9648,7 +9648,7 @@
                 <a:ea typeface="Cambria" pitchFamily="34" charset="-122"/>
                 <a:cs typeface="Cambria" pitchFamily="34" charset="-120"/>
               </a:rPr>
-              <a:t>Cutting the bias gap without losing power</a:t>
+              <a:t>Measuring the bias gap — then narrowing it</a:t>
             </a:r>
             <a:endParaRPr lang="en-US" sz="3000" dirty="0"/>
           </a:p>
@@ -9997,7 +9997,7 @@
                           <a:ea typeface="Calibri" pitchFamily="34" charset="-122"/>
                           <a:cs typeface="Calibri" pitchFamily="34" charset="-120"/>
                         </a:rPr>
-                        <a:t>0.028</a:t>
+                        <a:t>0.0161</a:t>
                       </a:r>
                       <a:endParaRPr lang="en-US" sz="1350" dirty="0">
                         <a:latin typeface="Calibri" charset="0"/>
@@ -10065,7 +10065,7 @@
                           <a:ea typeface="Calibri" pitchFamily="34" charset="-122"/>
                           <a:cs typeface="Calibri" pitchFamily="34" charset="-120"/>
                         </a:rPr>
-                        <a:t>0.001</a:t>
+                        <a:t>0.0129</a:t>
                       </a:r>
                       <a:endParaRPr lang="en-US" sz="1350" dirty="0">
                         <a:latin typeface="Calibri" charset="0"/>
@@ -10203,7 +10203,7 @@
                           <a:ea typeface="Calibri" pitchFamily="34" charset="-122"/>
                           <a:cs typeface="Calibri" pitchFamily="34" charset="-120"/>
                         </a:rPr>
-                        <a:t>0.031</a:t>
+                        <a:t>0.0269</a:t>
                       </a:r>
                       <a:endParaRPr lang="en-US" sz="1350" dirty="0">
                         <a:latin typeface="Calibri" charset="0"/>
@@ -10271,7 +10271,7 @@
                           <a:ea typeface="Calibri" pitchFamily="34" charset="-122"/>
                           <a:cs typeface="Calibri" pitchFamily="34" charset="-120"/>
                         </a:rPr>
-                        <a:t>0.004</a:t>
+                        <a:t>0.0148</a:t>
                       </a:r>
                       <a:endParaRPr lang="en-US" sz="1350" dirty="0">
                         <a:latin typeface="Calibri" charset="0"/>
@@ -10409,7 +10409,7 @@
                           <a:ea typeface="Calibri" pitchFamily="34" charset="-122"/>
                           <a:cs typeface="Calibri" pitchFamily="34" charset="-120"/>
                         </a:rPr>
-                        <a:t>0.94</a:t>
+                        <a:t>0.944</a:t>
                       </a:r>
                       <a:endParaRPr lang="en-US" sz="1350" dirty="0">
                         <a:latin typeface="Calibri" charset="0"/>
@@ -10477,7 +10477,7 @@
                           <a:ea typeface="Calibri" pitchFamily="34" charset="-122"/>
                           <a:cs typeface="Calibri" pitchFamily="34" charset="-120"/>
                         </a:rPr>
-                        <a:t>0.99</a:t>
+                        <a:t>0.969</a:t>
                       </a:r>
                       <a:endParaRPr lang="en-US" sz="1350" dirty="0">
                         <a:latin typeface="Calibri" charset="0"/>
@@ -10641,7 +10641,7 @@
                 <a:ea typeface="Calibri" pitchFamily="34" charset="-122"/>
                 <a:cs typeface="Calibri" pitchFamily="34" charset="-120"/>
               </a:rPr>
-              <a:t>(male 0.375, female 0.355)</a:t>
+              <a:t>(male 0.385, female 0.36)</a:t>
             </a:r>
             <a:pPr indent="0" marL="0">
               <a:buNone/>
@@ -10708,7 +10708,7 @@
                 <a:ea typeface="Calibri" pitchFamily="34" charset="-122"/>
                 <a:cs typeface="Calibri" pitchFamily="34" charset="-120"/>
               </a:rPr>
-              <a:t>— the trained model is untouched, and ranking power (AUPRC) is unchanged. The equal-opportunity gap collapses ~97%.</a:t>
+              <a:t>— the trained model is untouched, ranking power (AUPRC) unchanged. The equal-opportunity gap narrows ~20%; the FPR gap widens (0.020→0.026), which points to equalized odds next.</a:t>
             </a:r>
             <a:endParaRPr lang="en-US" sz="1350" dirty="0"/>
           </a:p>
@@ -10902,9 +10902,48 @@
           </a:p>
         </p:txBody>
       </p:sp>
+      <p:sp>
+        <p:nvSpPr>
+          <p:cNvPr id="4" name="Text 2"/>
+          <p:cNvSpPr/>
+          <p:nvPr/>
+        </p:nvSpPr>
+        <p:spPr>
+          <a:xfrm>
+            <a:off x="548640" y="1645920"/>
+            <a:ext cx="5852160" cy="365760"/>
+          </a:xfrm>
+          <a:prstGeom prst="rect">
+            <a:avLst/>
+          </a:prstGeom>
+          <a:noFill/>
+          <a:ln/>
+        </p:spPr>
+        <p:txBody>
+          <a:bodyPr wrap="square" rtlCol="0" anchor="ctr"/>
+          <a:lstStyle/>
+          <a:p>
+            <a:pPr indent="0" marL="0">
+              <a:buNone/>
+            </a:pPr>
+            <a:r>
+              <a:rPr lang="en-US" sz="1600" b="1" dirty="0">
+                <a:solidFill>
+                  <a:srgbClr val="0F172A"/>
+                </a:solidFill>
+                <a:latin typeface="Cambria" pitchFamily="34" charset="0"/>
+                <a:ea typeface="Cambria" pitchFamily="34" charset="-122"/>
+                <a:cs typeface="Cambria" pitchFamily="34" charset="-120"/>
+              </a:rPr>
+              <a:t>Local — why this applicant (p = 0.96) was declined</a:t>
+            </a:r>
+            <a:endParaRPr lang="en-US" sz="1600" dirty="0"/>
+          </a:p>
+        </p:txBody>
+      </p:sp>
       <p:pic>
         <p:nvPicPr>
-          <p:cNvPr id="4" name="Image 0" descr="outputs/shap_summary.png">    </p:cNvPr>
+          <p:cNvPr id="5" name="Image 0" descr="outputs/shap_reasoncodes.png">    </p:cNvPr>
           <p:cNvPicPr>
             <a:picLocks noChangeAspect="1"/>
           </p:cNvPicPr>
@@ -10918,8 +10957,8 @@
         </p:blipFill>
         <p:spPr>
           <a:xfrm>
-            <a:off x="548640" y="1600200"/>
-            <a:ext cx="4572000" cy="4389120"/>
+            <a:off x="502920" y="2148840"/>
+            <a:ext cx="5806440" cy="3236976"/>
           </a:xfrm>
           <a:prstGeom prst="rect">
             <a:avLst/>
@@ -10928,14 +10967,14 @@
       </p:pic>
       <p:sp>
         <p:nvSpPr>
-          <p:cNvPr id="5" name="Text 2"/>
-          <p:cNvSpPr/>
-          <p:nvPr/>
-        </p:nvSpPr>
-        <p:spPr>
-          <a:xfrm>
-            <a:off x="5394960" y="1737360"/>
-            <a:ext cx="6309360" cy="1097280"/>
+          <p:cNvPr id="6" name="Text 3"/>
+          <p:cNvSpPr/>
+          <p:nvPr/>
+        </p:nvSpPr>
+        <p:spPr>
+          <a:xfrm>
+            <a:off x="6629400" y="1737360"/>
+            <a:ext cx="5029200" cy="365760"/>
           </a:xfrm>
           <a:prstGeom prst="rect">
             <a:avLst/>
@@ -10951,7 +10990,46 @@
               <a:buNone/>
             </a:pPr>
             <a:r>
-              <a:rPr lang="en-US" sz="1500" dirty="0">
+              <a:rPr lang="en-US" sz="1900" b="1" dirty="0">
+                <a:solidFill>
+                  <a:srgbClr val="0F172A"/>
+                </a:solidFill>
+                <a:latin typeface="Cambria" pitchFamily="34" charset="0"/>
+                <a:ea typeface="Cambria" pitchFamily="34" charset="-122"/>
+                <a:cs typeface="Cambria" pitchFamily="34" charset="-120"/>
+              </a:rPr>
+              <a:t>Global drivers</a:t>
+            </a:r>
+            <a:endParaRPr lang="en-US" sz="1900" dirty="0"/>
+          </a:p>
+        </p:txBody>
+      </p:sp>
+      <p:sp>
+        <p:nvSpPr>
+          <p:cNvPr id="7" name="Text 4"/>
+          <p:cNvSpPr/>
+          <p:nvPr/>
+        </p:nvSpPr>
+        <p:spPr>
+          <a:xfrm>
+            <a:off x="6629400" y="2240280"/>
+            <a:ext cx="5074920" cy="1188720"/>
+          </a:xfrm>
+          <a:prstGeom prst="rect">
+            <a:avLst/>
+          </a:prstGeom>
+          <a:noFill/>
+          <a:ln/>
+        </p:spPr>
+        <p:txBody>
+          <a:bodyPr wrap="square" rtlCol="0" anchor="ctr"/>
+          <a:lstStyle/>
+          <a:p>
+            <a:pPr indent="0" marL="0">
+              <a:buNone/>
+            </a:pPr>
+            <a:r>
+              <a:rPr lang="en-US" sz="1450" dirty="0">
                 <a:solidFill>
                   <a:srgbClr val="475569"/>
                 </a:solidFill>
@@ -10959,22 +11037,22 @@
                 <a:ea typeface="Calibri" pitchFamily="34" charset="-122"/>
                 <a:cs typeface="Calibri" pitchFamily="34" charset="-120"/>
               </a:rPr>
-              <a:t>Global: across the portfolio, most-recent repayment status, delinquent months, and worst delay dominate default risk — consistent with credit intuition.</a:t>
-            </a:r>
-            <a:endParaRPr lang="en-US" sz="1500" dirty="0"/>
-          </a:p>
-        </p:txBody>
-      </p:sp>
-      <p:sp>
-        <p:nvSpPr>
-          <p:cNvPr id="6" name="Text 3"/>
-          <p:cNvSpPr/>
-          <p:nvPr/>
-        </p:nvSpPr>
-        <p:spPr>
-          <a:xfrm>
-            <a:off x="5394960" y="2926080"/>
-            <a:ext cx="6309360" cy="365760"/>
+              <a:t>Across the whole portfolio the same signals dominate: most-recent repayment status, months in arrears, and worst delay — consistent with credit intuition.</a:t>
+            </a:r>
+            <a:endParaRPr lang="en-US" sz="1450" dirty="0"/>
+          </a:p>
+        </p:txBody>
+      </p:sp>
+      <p:sp>
+        <p:nvSpPr>
+          <p:cNvPr id="8" name="Text 5"/>
+          <p:cNvSpPr/>
+          <p:nvPr/>
+        </p:nvSpPr>
+        <p:spPr>
+          <a:xfrm>
+            <a:off x="6629400" y="3566160"/>
+            <a:ext cx="5029200" cy="365760"/>
           </a:xfrm>
           <a:prstGeom prst="rect">
             <a:avLst/>
@@ -10990,7 +11068,7 @@
               <a:buNone/>
             </a:pPr>
             <a:r>
-              <a:rPr lang="en-US" sz="1700" b="1" dirty="0">
+              <a:rPr lang="en-US" sz="1900" b="1" dirty="0">
                 <a:solidFill>
                   <a:srgbClr val="0F172A"/>
                 </a:solidFill>
@@ -10998,34 +11076,73 @@
                 <a:ea typeface="Cambria" pitchFamily="34" charset="-122"/>
                 <a:cs typeface="Cambria" pitchFamily="34" charset="-120"/>
               </a:rPr>
-              <a:t>Local: reason codes for a high-risk applicant (p = 0.96)</a:t>
-            </a:r>
-            <a:endParaRPr lang="en-US" sz="1700" dirty="0"/>
-          </a:p>
-        </p:txBody>
-      </p:sp>
-      <p:sp>
-        <p:nvSpPr>
-          <p:cNvPr id="7" name="Shape 4"/>
-          <p:cNvSpPr/>
-          <p:nvPr/>
-        </p:nvSpPr>
-        <p:spPr>
-          <a:xfrm>
-            <a:off x="5394960" y="3429000"/>
-            <a:ext cx="6309360" cy="566928"/>
+              <a:t>Adverse-action reasons</a:t>
+            </a:r>
+            <a:endParaRPr lang="en-US" sz="1900" dirty="0"/>
+          </a:p>
+        </p:txBody>
+      </p:sp>
+      <p:sp>
+        <p:nvSpPr>
+          <p:cNvPr id="9" name="Text 6"/>
+          <p:cNvSpPr/>
+          <p:nvPr/>
+        </p:nvSpPr>
+        <p:spPr>
+          <a:xfrm>
+            <a:off x="6629400" y="4069080"/>
+            <a:ext cx="5074920" cy="1097280"/>
+          </a:xfrm>
+          <a:prstGeom prst="rect">
+            <a:avLst/>
+          </a:prstGeom>
+          <a:noFill/>
+          <a:ln/>
+        </p:spPr>
+        <p:txBody>
+          <a:bodyPr wrap="square" rtlCol="0" anchor="ctr"/>
+          <a:lstStyle/>
+          <a:p>
+            <a:pPr indent="0" marL="0">
+              <a:buNone/>
+            </a:pPr>
+            <a:r>
+              <a:rPr lang="en-US" sz="1450" dirty="0">
+                <a:solidFill>
+                  <a:srgbClr val="475569"/>
+                </a:solidFill>
+                <a:latin typeface="Calibri" pitchFamily="34" charset="0"/>
+                <a:ea typeface="Calibri" pitchFamily="34" charset="-122"/>
+                <a:cs typeface="Calibri" pitchFamily="34" charset="-120"/>
+              </a:rPr>
+              <a:t>For any declined applicant the model emits ranked, plain-language reasons — exactly the disclosure a lender is legally required to give.</a:t>
+            </a:r>
+            <a:endParaRPr lang="en-US" sz="1450" dirty="0"/>
+          </a:p>
+        </p:txBody>
+      </p:sp>
+      <p:sp>
+        <p:nvSpPr>
+          <p:cNvPr id="10" name="Shape 7"/>
+          <p:cNvSpPr/>
+          <p:nvPr/>
+        </p:nvSpPr>
+        <p:spPr>
+          <a:xfrm>
+            <a:off x="6629400" y="5166360"/>
+            <a:ext cx="5074920" cy="1051560"/>
           </a:xfrm>
           <a:prstGeom prst="roundRect">
             <a:avLst>
-              <a:gd name="adj" fmla="val 9677"/>
+              <a:gd name="adj" fmla="val 8696"/>
             </a:avLst>
           </a:prstGeom>
           <a:solidFill>
-            <a:srgbClr val="F8FAFC"/>
+            <a:srgbClr val="ECFDF5"/>
           </a:solidFill>
-          <a:ln w="12700">
+          <a:ln w="19050">
             <a:solidFill>
-              <a:srgbClr val="F1F5F9"/>
+              <a:srgbClr val="10B981"/>
             </a:solidFill>
             <a:prstDash val="solid"/>
           </a:ln>
@@ -11033,14 +11150,14 @@
       </p:sp>
       <p:sp>
         <p:nvSpPr>
-          <p:cNvPr id="8" name="Text 5"/>
-          <p:cNvSpPr/>
-          <p:nvPr/>
-        </p:nvSpPr>
-        <p:spPr>
-          <a:xfrm>
-            <a:off x="5532120" y="3429000"/>
-            <a:ext cx="2286000" cy="566928"/>
+          <p:cNvPr id="11" name="Text 8"/>
+          <p:cNvSpPr/>
+          <p:nvPr/>
+        </p:nvSpPr>
+        <p:spPr>
+          <a:xfrm>
+            <a:off x="6812280" y="5257800"/>
+            <a:ext cx="4754880" cy="868680"/>
           </a:xfrm>
           <a:prstGeom prst="rect">
             <a:avLst/>
@@ -11056,46 +11173,21 @@
               <a:buNone/>
             </a:pPr>
             <a:r>
-              <a:rPr lang="en-US" sz="1350" b="1" dirty="0">
-                <a:solidFill>
-                  <a:srgbClr val="0F172A"/>
+              <a:rPr lang="en-US" sz="1250" b="1" dirty="0">
+                <a:solidFill>
+                  <a:srgbClr val="0E9C6E"/>
                 </a:solidFill>
                 <a:latin typeface="Calibri" pitchFamily="34" charset="0"/>
                 <a:ea typeface="Calibri" pitchFamily="34" charset="-122"/>
                 <a:cs typeface="Calibri" pitchFamily="34" charset="-120"/>
               </a:rPr>
-              <a:t>PAY_1 = 3</a:t>
-            </a:r>
-            <a:endParaRPr lang="en-US" sz="1350" dirty="0"/>
-          </a:p>
-        </p:txBody>
-      </p:sp>
-      <p:sp>
-        <p:nvSpPr>
-          <p:cNvPr id="9" name="Text 6"/>
-          <p:cNvSpPr/>
-          <p:nvPr/>
-        </p:nvSpPr>
-        <p:spPr>
-          <a:xfrm>
-            <a:off x="7772400" y="3429000"/>
-            <a:ext cx="2926080" cy="566928"/>
-          </a:xfrm>
-          <a:prstGeom prst="rect">
-            <a:avLst/>
-          </a:prstGeom>
-          <a:noFill/>
-          <a:ln/>
-        </p:spPr>
-        <p:txBody>
-          <a:bodyPr wrap="square" rtlCol="0" anchor="ctr"/>
-          <a:lstStyle/>
-          <a:p>
+              <a:t>Verified faithful: </a:t>
+            </a:r>
             <a:pPr indent="0" marL="0">
               <a:buNone/>
             </a:pPr>
             <a:r>
-              <a:rPr lang="en-US" sz="1200" dirty="0">
+              <a:rPr lang="en-US" sz="1250" dirty="0">
                 <a:solidFill>
                   <a:srgbClr val="475569"/>
                 </a:solidFill>
@@ -11103,22 +11195,22 @@
                 <a:ea typeface="Calibri" pitchFamily="34" charset="-122"/>
                 <a:cs typeface="Calibri" pitchFamily="34" charset="-120"/>
               </a:rPr>
-              <a:t>three months delayed on the latest bill</a:t>
-            </a:r>
-            <a:endParaRPr lang="en-US" sz="1200" dirty="0"/>
-          </a:p>
-        </p:txBody>
-      </p:sp>
-      <p:sp>
-        <p:nvSpPr>
-          <p:cNvPr id="10" name="Text 7"/>
-          <p:cNvSpPr/>
-          <p:nvPr/>
-        </p:nvSpPr>
-        <p:spPr>
-          <a:xfrm>
-            <a:off x="10698480" y="3429000"/>
-            <a:ext cx="868680" cy="566928"/>
+              <a:t>sigmoid(base + Σ SHAP) matches the model probability to 1e-4 — the explanation is arithmetic, not decoration.</a:t>
+            </a:r>
+            <a:endParaRPr lang="en-US" sz="1250" dirty="0"/>
+          </a:p>
+        </p:txBody>
+      </p:sp>
+      <p:sp>
+        <p:nvSpPr>
+          <p:cNvPr id="12" name="Text 9"/>
+          <p:cNvSpPr/>
+          <p:nvPr/>
+        </p:nvSpPr>
+        <p:spPr>
+          <a:xfrm>
+            <a:off x="11365992" y="6400800"/>
+            <a:ext cx="457200" cy="274320"/>
           </a:xfrm>
           <a:prstGeom prst="rect">
             <a:avLst/>
@@ -11134,533 +11226,23 @@
               <a:buNone/>
             </a:pPr>
             <a:r>
-              <a:rPr lang="en-US" sz="1500" b="1" dirty="0">
-                <a:solidFill>
-                  <a:srgbClr val="EF4444"/>
-                </a:solidFill>
-                <a:latin typeface="Cambria" pitchFamily="34" charset="0"/>
-                <a:ea typeface="Cambria" pitchFamily="34" charset="-122"/>
-                <a:cs typeface="Cambria" pitchFamily="34" charset="-120"/>
-              </a:rPr>
-              <a:t>+0.86</a:t>
-            </a:r>
-            <a:endParaRPr lang="en-US" sz="1500" dirty="0"/>
-          </a:p>
-        </p:txBody>
-      </p:sp>
-      <p:sp>
-        <p:nvSpPr>
-          <p:cNvPr id="11" name="Shape 8"/>
-          <p:cNvSpPr/>
-          <p:nvPr/>
-        </p:nvSpPr>
-        <p:spPr>
-          <a:xfrm>
-            <a:off x="5394960" y="4087368"/>
-            <a:ext cx="6309360" cy="566928"/>
-          </a:xfrm>
-          <a:prstGeom prst="roundRect">
-            <a:avLst>
-              <a:gd name="adj" fmla="val 9677"/>
-            </a:avLst>
-          </a:prstGeom>
-          <a:solidFill>
-            <a:srgbClr val="F8FAFC"/>
-          </a:solidFill>
-          <a:ln w="12700">
-            <a:solidFill>
-              <a:srgbClr val="F1F5F9"/>
-            </a:solidFill>
-            <a:prstDash val="solid"/>
-          </a:ln>
-        </p:spPr>
-      </p:sp>
-      <p:sp>
-        <p:nvSpPr>
-          <p:cNvPr id="12" name="Text 9"/>
-          <p:cNvSpPr/>
-          <p:nvPr/>
-        </p:nvSpPr>
-        <p:spPr>
-          <a:xfrm>
-            <a:off x="5532120" y="4087368"/>
-            <a:ext cx="2286000" cy="566928"/>
-          </a:xfrm>
-          <a:prstGeom prst="rect">
-            <a:avLst/>
-          </a:prstGeom>
-          <a:noFill/>
-          <a:ln/>
-        </p:spPr>
-        <p:txBody>
-          <a:bodyPr wrap="square" rtlCol="0" anchor="ctr"/>
-          <a:lstStyle/>
-          <a:p>
-            <a:pPr indent="0" marL="0">
-              <a:buNone/>
-            </a:pPr>
-            <a:r>
-              <a:rPr lang="en-US" sz="1350" b="1" dirty="0">
-                <a:solidFill>
-                  <a:srgbClr val="0F172A"/>
+              <a:rPr lang="en-US" sz="1000" dirty="0">
+                <a:solidFill>
+                  <a:srgbClr val="8CA0B3"/>
                 </a:solidFill>
                 <a:latin typeface="Calibri" pitchFamily="34" charset="0"/>
                 <a:ea typeface="Calibri" pitchFamily="34" charset="-122"/>
                 <a:cs typeface="Calibri" pitchFamily="34" charset="-120"/>
               </a:rPr>
-              <a:t>DELINQ_MONTHS = 6</a:t>
-            </a:r>
-            <a:endParaRPr lang="en-US" sz="1350" dirty="0"/>
+              <a:t>07</a:t>
+            </a:r>
+            <a:endParaRPr lang="en-US" sz="1000" dirty="0"/>
           </a:p>
         </p:txBody>
       </p:sp>
       <p:sp>
         <p:nvSpPr>
           <p:cNvPr id="13" name="Text 10"/>
-          <p:cNvSpPr/>
-          <p:nvPr/>
-        </p:nvSpPr>
-        <p:spPr>
-          <a:xfrm>
-            <a:off x="7772400" y="4087368"/>
-            <a:ext cx="2926080" cy="566928"/>
-          </a:xfrm>
-          <a:prstGeom prst="rect">
-            <a:avLst/>
-          </a:prstGeom>
-          <a:noFill/>
-          <a:ln/>
-        </p:spPr>
-        <p:txBody>
-          <a:bodyPr wrap="square" rtlCol="0" anchor="ctr"/>
-          <a:lstStyle/>
-          <a:p>
-            <a:pPr indent="0" marL="0">
-              <a:buNone/>
-            </a:pPr>
-            <a:r>
-              <a:rPr lang="en-US" sz="1200" dirty="0">
-                <a:solidFill>
-                  <a:srgbClr val="475569"/>
-                </a:solidFill>
-                <a:latin typeface="Calibri" pitchFamily="34" charset="0"/>
-                <a:ea typeface="Calibri" pitchFamily="34" charset="-122"/>
-                <a:cs typeface="Calibri" pitchFamily="34" charset="-120"/>
-              </a:rPr>
-              <a:t>in arrears every month of the panel</a:t>
-            </a:r>
-            <a:endParaRPr lang="en-US" sz="1200" dirty="0"/>
-          </a:p>
-        </p:txBody>
-      </p:sp>
-      <p:sp>
-        <p:nvSpPr>
-          <p:cNvPr id="14" name="Text 11"/>
-          <p:cNvSpPr/>
-          <p:nvPr/>
-        </p:nvSpPr>
-        <p:spPr>
-          <a:xfrm>
-            <a:off x="10698480" y="4087368"/>
-            <a:ext cx="868680" cy="566928"/>
-          </a:xfrm>
-          <a:prstGeom prst="rect">
-            <a:avLst/>
-          </a:prstGeom>
-          <a:noFill/>
-          <a:ln/>
-        </p:spPr>
-        <p:txBody>
-          <a:bodyPr wrap="square" rtlCol="0" anchor="ctr"/>
-          <a:lstStyle/>
-          <a:p>
-            <a:pPr algn="r" indent="0" marL="0">
-              <a:buNone/>
-            </a:pPr>
-            <a:r>
-              <a:rPr lang="en-US" sz="1500" b="1" dirty="0">
-                <a:solidFill>
-                  <a:srgbClr val="EF4444"/>
-                </a:solidFill>
-                <a:latin typeface="Cambria" pitchFamily="34" charset="0"/>
-                <a:ea typeface="Cambria" pitchFamily="34" charset="-122"/>
-                <a:cs typeface="Cambria" pitchFamily="34" charset="-120"/>
-              </a:rPr>
-              <a:t>+0.54</a:t>
-            </a:r>
-            <a:endParaRPr lang="en-US" sz="1500" dirty="0"/>
-          </a:p>
-        </p:txBody>
-      </p:sp>
-      <p:sp>
-        <p:nvSpPr>
-          <p:cNvPr id="15" name="Shape 12"/>
-          <p:cNvSpPr/>
-          <p:nvPr/>
-        </p:nvSpPr>
-        <p:spPr>
-          <a:xfrm>
-            <a:off x="5394960" y="4745736"/>
-            <a:ext cx="6309360" cy="566928"/>
-          </a:xfrm>
-          <a:prstGeom prst="roundRect">
-            <a:avLst>
-              <a:gd name="adj" fmla="val 9677"/>
-            </a:avLst>
-          </a:prstGeom>
-          <a:solidFill>
-            <a:srgbClr val="F8FAFC"/>
-          </a:solidFill>
-          <a:ln w="12700">
-            <a:solidFill>
-              <a:srgbClr val="F1F5F9"/>
-            </a:solidFill>
-            <a:prstDash val="solid"/>
-          </a:ln>
-        </p:spPr>
-      </p:sp>
-      <p:sp>
-        <p:nvSpPr>
-          <p:cNvPr id="16" name="Text 13"/>
-          <p:cNvSpPr/>
-          <p:nvPr/>
-        </p:nvSpPr>
-        <p:spPr>
-          <a:xfrm>
-            <a:off x="5532120" y="4745736"/>
-            <a:ext cx="2286000" cy="566928"/>
-          </a:xfrm>
-          <a:prstGeom prst="rect">
-            <a:avLst/>
-          </a:prstGeom>
-          <a:noFill/>
-          <a:ln/>
-        </p:spPr>
-        <p:txBody>
-          <a:bodyPr wrap="square" rtlCol="0" anchor="ctr"/>
-          <a:lstStyle/>
-          <a:p>
-            <a:pPr indent="0" marL="0">
-              <a:buNone/>
-            </a:pPr>
-            <a:r>
-              <a:rPr lang="en-US" sz="1350" b="1" dirty="0">
-                <a:solidFill>
-                  <a:srgbClr val="0F172A"/>
-                </a:solidFill>
-                <a:latin typeface="Calibri" pitchFamily="34" charset="0"/>
-                <a:ea typeface="Calibri" pitchFamily="34" charset="-122"/>
-                <a:cs typeface="Calibri" pitchFamily="34" charset="-120"/>
-              </a:rPr>
-              <a:t>MAX_DELAY = 7</a:t>
-            </a:r>
-            <a:endParaRPr lang="en-US" sz="1350" dirty="0"/>
-          </a:p>
-        </p:txBody>
-      </p:sp>
-      <p:sp>
-        <p:nvSpPr>
-          <p:cNvPr id="17" name="Text 14"/>
-          <p:cNvSpPr/>
-          <p:nvPr/>
-        </p:nvSpPr>
-        <p:spPr>
-          <a:xfrm>
-            <a:off x="7772400" y="4745736"/>
-            <a:ext cx="2926080" cy="566928"/>
-          </a:xfrm>
-          <a:prstGeom prst="rect">
-            <a:avLst/>
-          </a:prstGeom>
-          <a:noFill/>
-          <a:ln/>
-        </p:spPr>
-        <p:txBody>
-          <a:bodyPr wrap="square" rtlCol="0" anchor="ctr"/>
-          <a:lstStyle/>
-          <a:p>
-            <a:pPr indent="0" marL="0">
-              <a:buNone/>
-            </a:pPr>
-            <a:r>
-              <a:rPr lang="en-US" sz="1200" dirty="0">
-                <a:solidFill>
-                  <a:srgbClr val="475569"/>
-                </a:solidFill>
-                <a:latin typeface="Calibri" pitchFamily="34" charset="0"/>
-                <a:ea typeface="Calibri" pitchFamily="34" charset="-122"/>
-                <a:cs typeface="Calibri" pitchFamily="34" charset="-120"/>
-              </a:rPr>
-              <a:t>worst delay of seven months</a:t>
-            </a:r>
-            <a:endParaRPr lang="en-US" sz="1200" dirty="0"/>
-          </a:p>
-        </p:txBody>
-      </p:sp>
-      <p:sp>
-        <p:nvSpPr>
-          <p:cNvPr id="18" name="Text 15"/>
-          <p:cNvSpPr/>
-          <p:nvPr/>
-        </p:nvSpPr>
-        <p:spPr>
-          <a:xfrm>
-            <a:off x="10698480" y="4745736"/>
-            <a:ext cx="868680" cy="566928"/>
-          </a:xfrm>
-          <a:prstGeom prst="rect">
-            <a:avLst/>
-          </a:prstGeom>
-          <a:noFill/>
-          <a:ln/>
-        </p:spPr>
-        <p:txBody>
-          <a:bodyPr wrap="square" rtlCol="0" anchor="ctr"/>
-          <a:lstStyle/>
-          <a:p>
-            <a:pPr algn="r" indent="0" marL="0">
-              <a:buNone/>
-            </a:pPr>
-            <a:r>
-              <a:rPr lang="en-US" sz="1500" b="1" dirty="0">
-                <a:solidFill>
-                  <a:srgbClr val="EF4444"/>
-                </a:solidFill>
-                <a:latin typeface="Cambria" pitchFamily="34" charset="0"/>
-                <a:ea typeface="Cambria" pitchFamily="34" charset="-122"/>
-                <a:cs typeface="Cambria" pitchFamily="34" charset="-120"/>
-              </a:rPr>
-              <a:t>+0.39</a:t>
-            </a:r>
-            <a:endParaRPr lang="en-US" sz="1500" dirty="0"/>
-          </a:p>
-        </p:txBody>
-      </p:sp>
-      <p:sp>
-        <p:nvSpPr>
-          <p:cNvPr id="19" name="Shape 16"/>
-          <p:cNvSpPr/>
-          <p:nvPr/>
-        </p:nvSpPr>
-        <p:spPr>
-          <a:xfrm>
-            <a:off x="5394960" y="5404104"/>
-            <a:ext cx="6309360" cy="566928"/>
-          </a:xfrm>
-          <a:prstGeom prst="roundRect">
-            <a:avLst>
-              <a:gd name="adj" fmla="val 9677"/>
-            </a:avLst>
-          </a:prstGeom>
-          <a:solidFill>
-            <a:srgbClr val="F8FAFC"/>
-          </a:solidFill>
-          <a:ln w="12700">
-            <a:solidFill>
-              <a:srgbClr val="F1F5F9"/>
-            </a:solidFill>
-            <a:prstDash val="solid"/>
-          </a:ln>
-        </p:spPr>
-      </p:sp>
-      <p:sp>
-        <p:nvSpPr>
-          <p:cNvPr id="20" name="Text 17"/>
-          <p:cNvSpPr/>
-          <p:nvPr/>
-        </p:nvSpPr>
-        <p:spPr>
-          <a:xfrm>
-            <a:off x="5532120" y="5404104"/>
-            <a:ext cx="2286000" cy="566928"/>
-          </a:xfrm>
-          <a:prstGeom prst="rect">
-            <a:avLst/>
-          </a:prstGeom>
-          <a:noFill/>
-          <a:ln/>
-        </p:spPr>
-        <p:txBody>
-          <a:bodyPr wrap="square" rtlCol="0" anchor="ctr"/>
-          <a:lstStyle/>
-          <a:p>
-            <a:pPr indent="0" marL="0">
-              <a:buNone/>
-            </a:pPr>
-            <a:r>
-              <a:rPr lang="en-US" sz="1350" b="1" dirty="0">
-                <a:solidFill>
-                  <a:srgbClr val="0F172A"/>
-                </a:solidFill>
-                <a:latin typeface="Calibri" pitchFamily="34" charset="0"/>
-                <a:ea typeface="Calibri" pitchFamily="34" charset="-122"/>
-                <a:cs typeface="Calibri" pitchFamily="34" charset="-120"/>
-              </a:rPr>
-              <a:t>MEAN_DELAY = 4.7</a:t>
-            </a:r>
-            <a:endParaRPr lang="en-US" sz="1350" dirty="0"/>
-          </a:p>
-        </p:txBody>
-      </p:sp>
-      <p:sp>
-        <p:nvSpPr>
-          <p:cNvPr id="21" name="Text 18"/>
-          <p:cNvSpPr/>
-          <p:nvPr/>
-        </p:nvSpPr>
-        <p:spPr>
-          <a:xfrm>
-            <a:off x="7772400" y="5404104"/>
-            <a:ext cx="2926080" cy="566928"/>
-          </a:xfrm>
-          <a:prstGeom prst="rect">
-            <a:avLst/>
-          </a:prstGeom>
-          <a:noFill/>
-          <a:ln/>
-        </p:spPr>
-        <p:txBody>
-          <a:bodyPr wrap="square" rtlCol="0" anchor="ctr"/>
-          <a:lstStyle/>
-          <a:p>
-            <a:pPr indent="0" marL="0">
-              <a:buNone/>
-            </a:pPr>
-            <a:r>
-              <a:rPr lang="en-US" sz="1200" dirty="0">
-                <a:solidFill>
-                  <a:srgbClr val="475569"/>
-                </a:solidFill>
-                <a:latin typeface="Calibri" pitchFamily="34" charset="0"/>
-                <a:ea typeface="Calibri" pitchFamily="34" charset="-122"/>
-                <a:cs typeface="Calibri" pitchFamily="34" charset="-120"/>
-              </a:rPr>
-              <a:t>chronically late across the panel</a:t>
-            </a:r>
-            <a:endParaRPr lang="en-US" sz="1200" dirty="0"/>
-          </a:p>
-        </p:txBody>
-      </p:sp>
-      <p:sp>
-        <p:nvSpPr>
-          <p:cNvPr id="22" name="Text 19"/>
-          <p:cNvSpPr/>
-          <p:nvPr/>
-        </p:nvSpPr>
-        <p:spPr>
-          <a:xfrm>
-            <a:off x="10698480" y="5404104"/>
-            <a:ext cx="868680" cy="566928"/>
-          </a:xfrm>
-          <a:prstGeom prst="rect">
-            <a:avLst/>
-          </a:prstGeom>
-          <a:noFill/>
-          <a:ln/>
-        </p:spPr>
-        <p:txBody>
-          <a:bodyPr wrap="square" rtlCol="0" anchor="ctr"/>
-          <a:lstStyle/>
-          <a:p>
-            <a:pPr algn="r" indent="0" marL="0">
-              <a:buNone/>
-            </a:pPr>
-            <a:r>
-              <a:rPr lang="en-US" sz="1500" b="1" dirty="0">
-                <a:solidFill>
-                  <a:srgbClr val="EF4444"/>
-                </a:solidFill>
-                <a:latin typeface="Cambria" pitchFamily="34" charset="0"/>
-                <a:ea typeface="Cambria" pitchFamily="34" charset="-122"/>
-                <a:cs typeface="Cambria" pitchFamily="34" charset="-120"/>
-              </a:rPr>
-              <a:t>+0.15</a:t>
-            </a:r>
-            <a:endParaRPr lang="en-US" sz="1500" dirty="0"/>
-          </a:p>
-        </p:txBody>
-      </p:sp>
-      <p:sp>
-        <p:nvSpPr>
-          <p:cNvPr id="23" name="Text 20"/>
-          <p:cNvSpPr/>
-          <p:nvPr/>
-        </p:nvSpPr>
-        <p:spPr>
-          <a:xfrm>
-            <a:off x="5394960" y="6080760"/>
-            <a:ext cx="6309360" cy="365760"/>
-          </a:xfrm>
-          <a:prstGeom prst="rect">
-            <a:avLst/>
-          </a:prstGeom>
-          <a:noFill/>
-          <a:ln/>
-        </p:spPr>
-        <p:txBody>
-          <a:bodyPr wrap="square" rtlCol="0" anchor="ctr"/>
-          <a:lstStyle/>
-          <a:p>
-            <a:pPr indent="0" marL="0">
-              <a:buNone/>
-            </a:pPr>
-            <a:r>
-              <a:rPr lang="en-US" sz="1250" i="1" dirty="0">
-                <a:solidFill>
-                  <a:srgbClr val="0E9C6E"/>
-                </a:solidFill>
-                <a:latin typeface="Calibri" pitchFamily="34" charset="0"/>
-                <a:ea typeface="Calibri" pitchFamily="34" charset="-122"/>
-                <a:cs typeface="Calibri" pitchFamily="34" charset="-120"/>
-              </a:rPr>
-              <a:t>These are exactly the adverse-action reasons a lender must disclose.</a:t>
-            </a:r>
-            <a:endParaRPr lang="en-US" sz="1250" dirty="0"/>
-          </a:p>
-        </p:txBody>
-      </p:sp>
-      <p:sp>
-        <p:nvSpPr>
-          <p:cNvPr id="24" name="Text 21"/>
-          <p:cNvSpPr/>
-          <p:nvPr/>
-        </p:nvSpPr>
-        <p:spPr>
-          <a:xfrm>
-            <a:off x="11365992" y="6400800"/>
-            <a:ext cx="457200" cy="274320"/>
-          </a:xfrm>
-          <a:prstGeom prst="rect">
-            <a:avLst/>
-          </a:prstGeom>
-          <a:noFill/>
-          <a:ln/>
-        </p:spPr>
-        <p:txBody>
-          <a:bodyPr wrap="square" rtlCol="0" anchor="ctr"/>
-          <a:lstStyle/>
-          <a:p>
-            <a:pPr algn="r" indent="0" marL="0">
-              <a:buNone/>
-            </a:pPr>
-            <a:r>
-              <a:rPr lang="en-US" sz="1000" dirty="0">
-                <a:solidFill>
-                  <a:srgbClr val="8CA0B3"/>
-                </a:solidFill>
-                <a:latin typeface="Calibri" pitchFamily="34" charset="0"/>
-                <a:ea typeface="Calibri" pitchFamily="34" charset="-122"/>
-                <a:cs typeface="Calibri" pitchFamily="34" charset="-120"/>
-              </a:rPr>
-              <a:t>07</a:t>
-            </a:r>
-            <a:endParaRPr lang="en-US" sz="1000" dirty="0"/>
-          </a:p>
-        </p:txBody>
-      </p:sp>
-      <p:sp>
-        <p:nvSpPr>
-          <p:cNvPr id="25" name="Text 22"/>
           <p:cNvSpPr/>
           <p:nvPr/>
         </p:nvSpPr>
@@ -12476,7 +12058,7 @@
                 <a:ea typeface="Courier New" pitchFamily="34" charset="-122"/>
                 <a:cs typeface="Courier New" pitchFamily="34" charset="-120"/>
               </a:rPr>
-              <a:t>  "threshold": 0.355,</a:t>
+              <a:t>  "threshold": 0.375,</a:t>
             </a:r>
             <a:endParaRPr lang="en-US" sz="1250" dirty="0"/>
           </a:p>

</xml_diff>